<commit_message>
Publish validated Next.js project pipeline upload batch 2/2 - 2026-08-15 18:43
</commit_message>
<xml_diff>
--- a/website/public/generated/LMD-Bridgs/02_master_dashboard.pptx
+++ b/website/public/generated/LMD-Bridgs/02_master_dashboard.pptx
@@ -3425,7 +3425,7 @@
               </a:defRPr>
             </a:pPr>
             <a:r>
-              <a:t>Delayed</a:t>
+              <a:t>Active</a:t>
             </a:r>
           </a:p>
         </p:txBody>
@@ -3491,7 +3491,7 @@
               </a:defRPr>
             </a:pPr>
             <a:r>
-              <a:t>EGP 850,000,000</a:t>
+              <a:t>N/A</a:t>
             </a:r>
           </a:p>
         </p:txBody>
@@ -3557,7 +3557,7 @@
               </a:defRPr>
             </a:pPr>
             <a:r>
-              <a:t>EGP 327,454,000</a:t>
+              <a:t>N/A</a:t>
             </a:r>
           </a:p>
         </p:txBody>
@@ -3623,7 +3623,7 @@
               </a:defRPr>
             </a:pPr>
             <a:r>
-              <a:t>31.0%</a:t>
+              <a:t>N/A</a:t>
             </a:r>
           </a:p>
         </p:txBody>
@@ -3689,7 +3689,7 @@
               </a:defRPr>
             </a:pPr>
             <a:r>
-              <a:t>38.0%</a:t>
+              <a:t>N/A</a:t>
             </a:r>
           </a:p>
         </p:txBody>
@@ -3755,7 +3755,7 @@
               </a:defRPr>
             </a:pPr>
             <a:r>
-              <a:t>EGP 850,000,000 / EGP 343,174,699 / EGP 294,306,867 / EGP 311,965,280</a:t>
+              <a:t>N/A / N/A / N/A / N/A</a:t>
             </a:r>
           </a:p>
         </p:txBody>
@@ -3821,7 +3821,7 @@
               </a:defRPr>
             </a:pPr>
             <a:r>
-              <a:t>0.86 / 0.94</a:t>
+              <a:t>N/A / N/A</a:t>
             </a:r>
           </a:p>
         </p:txBody>
@@ -3856,7 +3856,7 @@
               </a:defRPr>
             </a:pPr>
             <a:r>
-              <a:t>Generated 13 Aug 2026 | Source-controlled selected-project output</a:t>
+              <a:t>Generated 15 Aug 2026 | Source-controlled selected-project output</a:t>
             </a:r>
           </a:p>
         </p:txBody>

</xml_diff>